<commit_message>
Fix BLUF slide title collision on all report PPTX templates
Default slide title placeholder overlapped the BOTTOM LINE UP FRONT
kicker; use a title-free slide with explicit title shape stacking.
Regenerate assets and add collision regression in tests.
</commit_message>
<xml_diff>
--- a/skills/presentations/assets/pptx/01-technical-review.pptx
+++ b/skills/presentations/assets/pptx/01-technical-review.pptx
@@ -5,16 +5,16 @@
     <p:sldMasterId xmlns:r="http://schemas.openxmlformats.org/officeDocument/2006/relationships" id="2147483648" r:id="rId1"/>
   </p:sldMasterIdLst>
   <p:notesMasterIdLst>
-    <p:notesMasterId r:id="R85d545dfef964055"/>
+    <p:notesMasterId r:id="R8c10dd12d1774ca4"/>
   </p:notesMasterIdLst>
   <p:sldIdLst>
-    <p:sldId id="256" r:id="Rc1628cdaabf4454f"/>
-    <p:sldId id="257" r:id="R01d0442028e54f15"/>
-    <p:sldId id="258" r:id="R3c2ff428ecec4725"/>
-    <p:sldId id="259" r:id="R2c10c04f1aad4b77"/>
-    <p:sldId id="260" r:id="R7edbd6f99cad4d50"/>
-    <p:sldId id="261" r:id="R1bc7deb34e1c44ce"/>
-    <p:sldId id="262" r:id="Rde8234fe903444cb"/>
+    <p:sldId id="256" r:id="Rfec5b1f4840d426a"/>
+    <p:sldId id="257" r:id="R59f98cded31b47ab"/>
+    <p:sldId id="258" r:id="R7f897b7bd7a747d3"/>
+    <p:sldId id="259" r:id="R7006156733a34187"/>
+    <p:sldId id="260" r:id="R45a60f9fff5542ea"/>
+    <p:sldId id="261" r:id="Rabe97c3d02564156"/>
+    <p:sldId id="262" r:id="Re448d4f0cd0b46eb"/>
   </p:sldIdLst>
   <p:sldSz cx="12192000" cy="6858000"/>
   <p:notesSz cx="6858000" cy="9144000"/>
@@ -1262,7 +1262,7 @@
 
 <file path=ppt/slides/slide2.xml><?xml version="1.0" encoding="utf-8"?>
 <p:sld xmlns:p="http://schemas.openxmlformats.org/presentationml/2006/main">
-  <p:cSld>
+  <p:cSld name="BLUF — decision needed">
     <p:bg>
       <p:bgPr>
         <a:solidFill xmlns:a="http://schemas.openxmlformats.org/drawingml/2006/main">
@@ -1279,39 +1279,14 @@
       <p:grpSpPr/>
       <p:sp>
         <p:nvSpPr>
-          <p:cNvPr id="2" name="Title"/>
-          <p:cNvSpPr/>
-          <p:nvPr>
-            <p:ph type="title"/>
-          </p:nvPr>
-        </p:nvSpPr>
-        <p:spPr>
-          <a:xfrm xmlns:a="http://schemas.openxmlformats.org/drawingml/2006/main">
-            <a:off x="838200" y="365125"/>
-            <a:ext cx="10515600" cy="1320800"/>
-          </a:xfrm>
-        </p:spPr>
-        <p:txBody>
-          <a:bodyPr xmlns:a="http://schemas.openxmlformats.org/drawingml/2006/main"/>
-          <a:lstStyle xmlns:a="http://schemas.openxmlformats.org/drawingml/2006/main"/>
-          <a:p xmlns:a="http://schemas.openxmlformats.org/drawingml/2006/main">
-            <a:r>
-              <a:rPr lang="en-US"/>
-              <a:t>BLUF — decision needed</a:t>
-            </a:r>
-          </a:p>
-        </p:txBody>
-      </p:sp>
-      <p:sp>
-        <p:nvSpPr>
-          <p:cNvPr id="100004" name="TextBox 2"/>
+          <p:cNvPr id="100004" name="TextBox 1"/>
           <p:cNvSpPr txBox="1"/>
           <p:nvPr/>
         </p:nvSpPr>
         <p:spPr>
           <a:xfrm xmlns:a="http://schemas.openxmlformats.org/drawingml/2006/main">
-            <a:off x="540000" y="540000"/>
-            <a:ext cx="5040000" cy="324000"/>
+            <a:off x="540000" y="432000"/>
+            <a:ext cx="10980000" cy="720000"/>
           </a:xfrm>
           <a:prstGeom xmlns:a="http://schemas.openxmlformats.org/drawingml/2006/main" prst="rect">
             <a:avLst/>
@@ -1322,7 +1297,39 @@
           <a:lstStyle xmlns:a="http://schemas.openxmlformats.org/drawingml/2006/main"/>
           <a:p xmlns:a="http://schemas.openxmlformats.org/drawingml/2006/main">
             <a:r>
-              <a:rPr lang="en-US" sz="1400" b="1">
+              <a:rPr lang="en-US" sz="3200" b="1">
+                <a:solidFill>
+                  <a:srgbClr val="1A202C"/>
+                </a:solidFill>
+                <a:latin typeface="Calibri"/>
+                <a:ea typeface="Calibri"/>
+              </a:rPr>
+              <a:t>BLUF — decision needed</a:t>
+            </a:r>
+          </a:p>
+        </p:txBody>
+      </p:sp>
+      <p:sp>
+        <p:nvSpPr>
+          <p:cNvPr id="100005" name="TextBox 2"/>
+          <p:cNvSpPr txBox="1"/>
+          <p:nvPr/>
+        </p:nvSpPr>
+        <p:spPr>
+          <a:xfrm xmlns:a="http://schemas.openxmlformats.org/drawingml/2006/main">
+            <a:off x="540000" y="1188000"/>
+            <a:ext cx="5760000" cy="306000"/>
+          </a:xfrm>
+          <a:prstGeom xmlns:a="http://schemas.openxmlformats.org/drawingml/2006/main" prst="rect">
+            <a:avLst/>
+          </a:prstGeom>
+        </p:spPr>
+        <p:txBody>
+          <a:bodyPr xmlns:a="http://schemas.openxmlformats.org/drawingml/2006/main"/>
+          <a:lstStyle xmlns:a="http://schemas.openxmlformats.org/drawingml/2006/main"/>
+          <a:p xmlns:a="http://schemas.openxmlformats.org/drawingml/2006/main">
+            <a:r>
+              <a:rPr lang="en-US" sz="1200" b="1">
                 <a:solidFill>
                   <a:srgbClr val="2B6CB0"/>
                 </a:solidFill>
@@ -1336,7 +1343,7 @@
       </p:sp>
       <p:sp>
         <p:nvSpPr>
-          <p:cNvPr id="100005" name="TextBox 3"/>
+          <p:cNvPr id="100006" name="TextBox 3"/>
           <p:cNvSpPr txBox="1"/>
           <p:nvPr/>
         </p:nvSpPr>
@@ -1371,7 +1378,7 @@
       </p:sp>
       <p:sp>
         <p:nvSpPr>
-          <p:cNvPr id="100006" name="TextBox 4"/>
+          <p:cNvPr id="100007" name="TextBox 4"/>
           <p:cNvSpPr txBox="1"/>
           <p:nvPr/>
         </p:nvSpPr>
@@ -1525,7 +1532,7 @@
       </p:sp>
       <p:sp>
         <p:nvSpPr>
-          <p:cNvPr id="100007" name="TextBox 2"/>
+          <p:cNvPr id="100008" name="TextBox 2"/>
           <p:cNvSpPr txBox="1"/>
           <p:nvPr/>
         </p:nvSpPr>
@@ -1679,7 +1686,7 @@
       </p:sp>
       <p:sp>
         <p:nvSpPr>
-          <p:cNvPr id="100008" name="TextBox 2"/>
+          <p:cNvPr id="100009" name="TextBox 2"/>
           <p:cNvSpPr txBox="1"/>
           <p:nvPr/>
         </p:nvSpPr>
@@ -1833,7 +1840,7 @@
       </p:sp>
       <p:sp>
         <p:nvSpPr>
-          <p:cNvPr id="100009" name="TextBox 2"/>
+          <p:cNvPr id="100010" name="TextBox 2"/>
           <p:cNvSpPr txBox="1"/>
           <p:nvPr/>
         </p:nvSpPr>
@@ -1963,7 +1970,7 @@
       </p:sp>
       <p:sp>
         <p:nvSpPr>
-          <p:cNvPr id="100010" name="TextBox 2"/>
+          <p:cNvPr id="100011" name="TextBox 2"/>
           <p:cNvSpPr txBox="1"/>
           <p:nvPr/>
         </p:nvSpPr>
@@ -1995,7 +2002,7 @@
       </p:sp>
       <p:graphicFrame>
         <p:nvGraphicFramePr>
-          <p:cNvPr id="100011" name="Table 1"/>
+          <p:cNvPr id="100012" name="Table 1"/>
           <p:cNvGraphicFramePr/>
           <p:nvPr/>
         </p:nvGraphicFramePr>
@@ -2535,7 +2542,7 @@
       </p:sp>
       <p:sp>
         <p:nvSpPr>
-          <p:cNvPr id="100012" name="TextBox 2"/>
+          <p:cNvPr id="100013" name="TextBox 2"/>
           <p:cNvSpPr txBox="1"/>
           <p:nvPr/>
         </p:nvSpPr>
@@ -2567,7 +2574,7 @@
       </p:sp>
       <p:sp>
         <p:nvSpPr>
-          <p:cNvPr id="100013" name="TextBox 3"/>
+          <p:cNvPr id="100014" name="TextBox 3"/>
           <p:cNvSpPr txBox="1"/>
           <p:nvPr/>
         </p:nvSpPr>

</xml_diff>